<commit_message>
docs: mise à jour de la présentation de soutenance
Co-authored-by: Kaelan Grall <kaelan.grall@gmail.com>
</commit_message>
<xml_diff>
--- a/presentation.pptx
+++ b/presentation.pptx
@@ -17914,8 +17914,8 @@
         </p:nvSpPr>
         <p:spPr>
           <a:xfrm>
-            <a:off x="457200" y="411480"/>
-            <a:ext cx="228600" cy="38100"/>
+            <a:off x="0" y="0"/>
+            <a:ext cx="365760" cy="6858000"/>
           </a:xfrm>
           <a:prstGeom prst="rect">
             <a:avLst/>
@@ -17958,247 +17958,47 @@
         </p:nvSpPr>
         <p:spPr>
           <a:xfrm>
-            <a:off x="777240" y="292608"/>
-            <a:ext cx="7315200" cy="365760"/>
-          </a:xfrm>
-          <a:prstGeom prst="rect">
-            <a:avLst/>
-          </a:prstGeom>
-          <a:noFill/>
-        </p:spPr>
-        <p:txBody>
-          <a:bodyPr wrap="square" lIns="0" rIns="0" tIns="0" bIns="0" anchor="t">
-            <a:spAutoFit/>
-          </a:bodyPr>
-          <a:lstStyle/>
-          <a:p>
-            <a:pPr algn="l">
-              <a:lnSpc>
-                <a:spcPct val="115000"/>
-              </a:lnSpc>
-            </a:pPr>
-            <a:r>
-              <a:rPr sz="1000" b="1">
-                <a:solidFill>
-                  <a:srgbClr val="475569"/>
+            <a:off x="457200" y="3108960"/>
+            <a:ext cx="11430000" cy="640080"/>
+          </a:xfrm>
+          <a:prstGeom prst="rect">
+            <a:avLst/>
+          </a:prstGeom>
+          <a:noFill/>
+        </p:spPr>
+        <p:txBody>
+          <a:bodyPr wrap="square" lIns="0" rIns="0" tIns="0" bIns="0" anchor="t">
+            <a:spAutoFit/>
+          </a:bodyPr>
+          <a:lstStyle/>
+          <a:p>
+            <a:pPr algn="ctr">
+              <a:lnSpc>
+                <a:spcPct val="115000"/>
+              </a:lnSpc>
+            </a:pPr>
+            <a:r>
+              <a:rPr sz="5400" b="1">
+                <a:solidFill>
+                  <a:srgbClr val="0F172A"/>
                 </a:solidFill>
                 <a:latin typeface="Helvetica Neue"/>
               </a:rPr>
-              <a:t>SYNTHÈSE</a:t>
-            </a:r>
-          </a:p>
-        </p:txBody>
-      </p:sp>
-      <p:sp>
-        <p:nvSpPr>
-          <p:cNvPr id="5" name="TextBox 4"/>
-          <p:cNvSpPr txBox="1"/>
-          <p:nvPr/>
-        </p:nvSpPr>
-        <p:spPr>
-          <a:xfrm>
-            <a:off x="457200" y="640080"/>
-            <a:ext cx="10058400" cy="640080"/>
-          </a:xfrm>
-          <a:prstGeom prst="rect">
-            <a:avLst/>
-          </a:prstGeom>
-          <a:noFill/>
-        </p:spPr>
-        <p:txBody>
-          <a:bodyPr wrap="square" lIns="0" rIns="0" tIns="0" bIns="0" anchor="t">
-            <a:spAutoFit/>
-          </a:bodyPr>
-          <a:lstStyle/>
-          <a:p>
-            <a:pPr algn="l">
-              <a:lnSpc>
-                <a:spcPct val="115000"/>
-              </a:lnSpc>
-            </a:pPr>
-            <a:r>
-              <a:rPr sz="2800" b="1">
-                <a:solidFill>
-                  <a:srgbClr val="0F172A"/>
-                </a:solidFill>
-                <a:latin typeface="Helvetica Neue"/>
-              </a:rPr>
-              <a:t>Conclusion et perspectives</a:t>
-            </a:r>
-          </a:p>
-        </p:txBody>
-      </p:sp>
-      <p:sp>
-        <p:nvSpPr>
-          <p:cNvPr id="6" name="TextBox 5"/>
-          <p:cNvSpPr txBox="1"/>
-          <p:nvPr/>
-        </p:nvSpPr>
-        <p:spPr>
-          <a:xfrm>
-            <a:off x="10789920" y="457200"/>
-            <a:ext cx="914400" cy="274320"/>
-          </a:xfrm>
-          <a:prstGeom prst="rect">
-            <a:avLst/>
-          </a:prstGeom>
-          <a:noFill/>
-        </p:spPr>
-        <p:txBody>
-          <a:bodyPr wrap="square" lIns="0" rIns="0" tIns="0" bIns="0" anchor="t">
-            <a:spAutoFit/>
-          </a:bodyPr>
-          <a:lstStyle/>
-          <a:p>
-            <a:pPr algn="r">
-              <a:lnSpc>
-                <a:spcPct val="115000"/>
-              </a:lnSpc>
-            </a:pPr>
-            <a:r>
-              <a:rPr sz="1000" b="0">
-                <a:solidFill>
-                  <a:srgbClr val="94A3B8"/>
-                </a:solidFill>
-                <a:latin typeface="Helvetica Neue"/>
-              </a:rPr>
-              <a:t>8 / 9</a:t>
-            </a:r>
-          </a:p>
-        </p:txBody>
-      </p:sp>
-      <p:sp>
-        <p:nvSpPr>
-          <p:cNvPr id="7" name="Rectangle 6"/>
+              <a:t>Conclusion</a:t>
+            </a:r>
+          </a:p>
+        </p:txBody>
+      </p:sp>
+      <p:sp>
+        <p:nvSpPr>
+          <p:cNvPr id="5" name="Rectangle 4"/>
           <p:cNvSpPr/>
           <p:nvPr/>
         </p:nvSpPr>
         <p:spPr>
           <a:xfrm>
-            <a:off x="457200" y="6537960"/>
-            <a:ext cx="11247120" cy="9525"/>
-          </a:xfrm>
-          <a:prstGeom prst="rect">
-            <a:avLst/>
-          </a:prstGeom>
-          <a:solidFill>
-            <a:srgbClr val="E2E8F0"/>
-          </a:solidFill>
-          <a:ln>
-            <a:noFill/>
-          </a:ln>
-          <a:effectLst/>
-        </p:spPr>
-        <p:style>
-          <a:lnRef idx="1">
-            <a:schemeClr val="accent1"/>
-          </a:lnRef>
-          <a:fillRef idx="3">
-            <a:schemeClr val="accent1"/>
-          </a:fillRef>
-          <a:effectRef idx="2">
-            <a:schemeClr val="accent1"/>
-          </a:effectRef>
-          <a:fontRef idx="minor">
-            <a:schemeClr val="lt1"/>
-          </a:fontRef>
-        </p:style>
-        <p:txBody>
-          <a:bodyPr rtlCol="0" anchor="ctr"/>
-          <a:lstStyle/>
-          <a:p>
-            <a:pPr algn="ctr"/>
-          </a:p>
-        </p:txBody>
-      </p:sp>
-      <p:sp>
-        <p:nvSpPr>
-          <p:cNvPr id="8" name="TextBox 7"/>
-          <p:cNvSpPr txBox="1"/>
-          <p:nvPr/>
-        </p:nvSpPr>
-        <p:spPr>
-          <a:xfrm>
-            <a:off x="457200" y="6583680"/>
-            <a:ext cx="7315200" cy="228600"/>
-          </a:xfrm>
-          <a:prstGeom prst="rect">
-            <a:avLst/>
-          </a:prstGeom>
-          <a:noFill/>
-        </p:spPr>
-        <p:txBody>
-          <a:bodyPr wrap="square" lIns="0" rIns="0" tIns="0" bIns="0" anchor="t">
-            <a:spAutoFit/>
-          </a:bodyPr>
-          <a:lstStyle/>
-          <a:p>
-            <a:pPr algn="l">
-              <a:lnSpc>
-                <a:spcPct val="115000"/>
-              </a:lnSpc>
-            </a:pPr>
-            <a:r>
-              <a:rPr sz="900" b="0">
-                <a:solidFill>
-                  <a:srgbClr val="94A3B8"/>
-                </a:solidFill>
-                <a:latin typeface="Helvetica Neue"/>
-              </a:rPr>
-              <a:t>B1 — SALBP   ·   I. Kalalou &amp; K. Grall   ·   EPITA SCIA 2026</a:t>
-            </a:r>
-          </a:p>
-        </p:txBody>
-      </p:sp>
-      <p:sp>
-        <p:nvSpPr>
-          <p:cNvPr id="9" name="TextBox 8"/>
-          <p:cNvSpPr txBox="1"/>
-          <p:nvPr/>
-        </p:nvSpPr>
-        <p:spPr>
-          <a:xfrm>
-            <a:off x="457200" y="1554480"/>
-            <a:ext cx="5486400" cy="365760"/>
-          </a:xfrm>
-          <a:prstGeom prst="rect">
-            <a:avLst/>
-          </a:prstGeom>
-          <a:noFill/>
-        </p:spPr>
-        <p:txBody>
-          <a:bodyPr wrap="square" lIns="0" rIns="0" tIns="0" bIns="0" anchor="t">
-            <a:spAutoFit/>
-          </a:bodyPr>
-          <a:lstStyle/>
-          <a:p>
-            <a:pPr algn="l">
-              <a:lnSpc>
-                <a:spcPct val="115000"/>
-              </a:lnSpc>
-            </a:pPr>
-            <a:r>
-              <a:rPr sz="1000" b="1">
-                <a:solidFill>
-                  <a:srgbClr val="1E3A8A"/>
-                </a:solidFill>
-                <a:latin typeface="Helvetica Neue"/>
-              </a:rPr>
-              <a:t>CE QUI A ÉTÉ FAIT</a:t>
-            </a:r>
-          </a:p>
-        </p:txBody>
-      </p:sp>
-      <p:sp>
-        <p:nvSpPr>
-          <p:cNvPr id="10" name="Rectangle 9"/>
-          <p:cNvSpPr/>
-          <p:nvPr/>
-        </p:nvSpPr>
-        <p:spPr>
-          <a:xfrm>
-            <a:off x="457200" y="2029968"/>
-            <a:ext cx="109728" cy="109728"/>
+            <a:off x="5486400" y="4023360"/>
+            <a:ext cx="1280160" cy="28575"/>
           </a:xfrm>
           <a:prstGeom prst="rect">
             <a:avLst/>
@@ -18230,1285 +18030,6 @@
           <a:lstStyle/>
           <a:p>
             <a:pPr algn="ctr"/>
-          </a:p>
-        </p:txBody>
-      </p:sp>
-      <p:sp>
-        <p:nvSpPr>
-          <p:cNvPr id="11" name="TextBox 10"/>
-          <p:cNvSpPr txBox="1"/>
-          <p:nvPr/>
-        </p:nvSpPr>
-        <p:spPr>
-          <a:xfrm>
-            <a:off x="731520" y="1920240"/>
-            <a:ext cx="5029200" cy="365760"/>
-          </a:xfrm>
-          <a:prstGeom prst="rect">
-            <a:avLst/>
-          </a:prstGeom>
-          <a:noFill/>
-        </p:spPr>
-        <p:txBody>
-          <a:bodyPr wrap="square" lIns="0" rIns="0" tIns="0" bIns="0" anchor="t">
-            <a:spAutoFit/>
-          </a:bodyPr>
-          <a:lstStyle/>
-          <a:p>
-            <a:pPr algn="l">
-              <a:lnSpc>
-                <a:spcPct val="115000"/>
-              </a:lnSpc>
-            </a:pPr>
-            <a:r>
-              <a:rPr sz="1200" b="0">
-                <a:solidFill>
-                  <a:srgbClr val="0F172A"/>
-                </a:solidFill>
-                <a:latin typeface="Helvetica Neue"/>
-              </a:rPr>
-              <a:t>Modélisation CP-SAT complète SALBP-1 et SALBP-2</a:t>
-            </a:r>
-          </a:p>
-        </p:txBody>
-      </p:sp>
-      <p:sp>
-        <p:nvSpPr>
-          <p:cNvPr id="12" name="Rectangle 11"/>
-          <p:cNvSpPr/>
-          <p:nvPr/>
-        </p:nvSpPr>
-        <p:spPr>
-          <a:xfrm>
-            <a:off x="457200" y="2441448"/>
-            <a:ext cx="109728" cy="109728"/>
-          </a:xfrm>
-          <a:prstGeom prst="rect">
-            <a:avLst/>
-          </a:prstGeom>
-          <a:solidFill>
-            <a:srgbClr val="1E3A8A"/>
-          </a:solidFill>
-          <a:ln>
-            <a:noFill/>
-          </a:ln>
-          <a:effectLst/>
-        </p:spPr>
-        <p:style>
-          <a:lnRef idx="1">
-            <a:schemeClr val="accent1"/>
-          </a:lnRef>
-          <a:fillRef idx="3">
-            <a:schemeClr val="accent1"/>
-          </a:fillRef>
-          <a:effectRef idx="2">
-            <a:schemeClr val="accent1"/>
-          </a:effectRef>
-          <a:fontRef idx="minor">
-            <a:schemeClr val="lt1"/>
-          </a:fontRef>
-        </p:style>
-        <p:txBody>
-          <a:bodyPr rtlCol="0" anchor="ctr"/>
-          <a:lstStyle/>
-          <a:p>
-            <a:pPr algn="ctr"/>
-          </a:p>
-        </p:txBody>
-      </p:sp>
-      <p:sp>
-        <p:nvSpPr>
-          <p:cNvPr id="13" name="TextBox 12"/>
-          <p:cNvSpPr txBox="1"/>
-          <p:nvPr/>
-        </p:nvSpPr>
-        <p:spPr>
-          <a:xfrm>
-            <a:off x="731520" y="2331720"/>
-            <a:ext cx="5029200" cy="365760"/>
-          </a:xfrm>
-          <a:prstGeom prst="rect">
-            <a:avLst/>
-          </a:prstGeom>
-          <a:noFill/>
-        </p:spPr>
-        <p:txBody>
-          <a:bodyPr wrap="square" lIns="0" rIns="0" tIns="0" bIns="0" anchor="t">
-            <a:spAutoFit/>
-          </a:bodyPr>
-          <a:lstStyle/>
-          <a:p>
-            <a:pPr algn="l">
-              <a:lnSpc>
-                <a:spcPct val="115000"/>
-              </a:lnSpc>
-            </a:pPr>
-            <a:r>
-              <a:rPr sz="1200" b="0">
-                <a:solidFill>
-                  <a:srgbClr val="0F172A"/>
-                </a:solidFill>
-                <a:latin typeface="Helvetica Neue"/>
-              </a:rPr>
-              <a:t>Modèle PLNE équivalent (PuLP / CBC)</a:t>
-            </a:r>
-          </a:p>
-        </p:txBody>
-      </p:sp>
-      <p:sp>
-        <p:nvSpPr>
-          <p:cNvPr id="14" name="Rectangle 13"/>
-          <p:cNvSpPr/>
-          <p:nvPr/>
-        </p:nvSpPr>
-        <p:spPr>
-          <a:xfrm>
-            <a:off x="457200" y="2852928"/>
-            <a:ext cx="109728" cy="109728"/>
-          </a:xfrm>
-          <a:prstGeom prst="rect">
-            <a:avLst/>
-          </a:prstGeom>
-          <a:solidFill>
-            <a:srgbClr val="1E3A8A"/>
-          </a:solidFill>
-          <a:ln>
-            <a:noFill/>
-          </a:ln>
-          <a:effectLst/>
-        </p:spPr>
-        <p:style>
-          <a:lnRef idx="1">
-            <a:schemeClr val="accent1"/>
-          </a:lnRef>
-          <a:fillRef idx="3">
-            <a:schemeClr val="accent1"/>
-          </a:fillRef>
-          <a:effectRef idx="2">
-            <a:schemeClr val="accent1"/>
-          </a:effectRef>
-          <a:fontRef idx="minor">
-            <a:schemeClr val="lt1"/>
-          </a:fontRef>
-        </p:style>
-        <p:txBody>
-          <a:bodyPr rtlCol="0" anchor="ctr"/>
-          <a:lstStyle/>
-          <a:p>
-            <a:pPr algn="ctr"/>
-          </a:p>
-        </p:txBody>
-      </p:sp>
-      <p:sp>
-        <p:nvSpPr>
-          <p:cNvPr id="15" name="TextBox 14"/>
-          <p:cNvSpPr txBox="1"/>
-          <p:nvPr/>
-        </p:nvSpPr>
-        <p:spPr>
-          <a:xfrm>
-            <a:off x="731520" y="2743200"/>
-            <a:ext cx="5029200" cy="365760"/>
-          </a:xfrm>
-          <a:prstGeom prst="rect">
-            <a:avLst/>
-          </a:prstGeom>
-          <a:noFill/>
-        </p:spPr>
-        <p:txBody>
-          <a:bodyPr wrap="square" lIns="0" rIns="0" tIns="0" bIns="0" anchor="t">
-            <a:spAutoFit/>
-          </a:bodyPr>
-          <a:lstStyle/>
-          <a:p>
-            <a:pPr algn="l">
-              <a:lnSpc>
-                <a:spcPct val="115000"/>
-              </a:lnSpc>
-            </a:pPr>
-            <a:r>
-              <a:rPr sz="1200" b="0">
-                <a:solidFill>
-                  <a:srgbClr val="0F172A"/>
-                </a:solidFill>
-                <a:latin typeface="Helvetica Neue"/>
-              </a:rPr>
-              <a:t>Heuristique RPW from scratch</a:t>
-            </a:r>
-          </a:p>
-        </p:txBody>
-      </p:sp>
-      <p:sp>
-        <p:nvSpPr>
-          <p:cNvPr id="16" name="Rectangle 15"/>
-          <p:cNvSpPr/>
-          <p:nvPr/>
-        </p:nvSpPr>
-        <p:spPr>
-          <a:xfrm>
-            <a:off x="457200" y="3264408"/>
-            <a:ext cx="109728" cy="109728"/>
-          </a:xfrm>
-          <a:prstGeom prst="rect">
-            <a:avLst/>
-          </a:prstGeom>
-          <a:solidFill>
-            <a:srgbClr val="1E3A8A"/>
-          </a:solidFill>
-          <a:ln>
-            <a:noFill/>
-          </a:ln>
-          <a:effectLst/>
-        </p:spPr>
-        <p:style>
-          <a:lnRef idx="1">
-            <a:schemeClr val="accent1"/>
-          </a:lnRef>
-          <a:fillRef idx="3">
-            <a:schemeClr val="accent1"/>
-          </a:fillRef>
-          <a:effectRef idx="2">
-            <a:schemeClr val="accent1"/>
-          </a:effectRef>
-          <a:fontRef idx="minor">
-            <a:schemeClr val="lt1"/>
-          </a:fontRef>
-        </p:style>
-        <p:txBody>
-          <a:bodyPr rtlCol="0" anchor="ctr"/>
-          <a:lstStyle/>
-          <a:p>
-            <a:pPr algn="ctr"/>
-          </a:p>
-        </p:txBody>
-      </p:sp>
-      <p:sp>
-        <p:nvSpPr>
-          <p:cNvPr id="17" name="TextBox 16"/>
-          <p:cNvSpPr txBox="1"/>
-          <p:nvPr/>
-        </p:nvSpPr>
-        <p:spPr>
-          <a:xfrm>
-            <a:off x="731520" y="3154680"/>
-            <a:ext cx="5029200" cy="365760"/>
-          </a:xfrm>
-          <a:prstGeom prst="rect">
-            <a:avLst/>
-          </a:prstGeom>
-          <a:noFill/>
-        </p:spPr>
-        <p:txBody>
-          <a:bodyPr wrap="square" lIns="0" rIns="0" tIns="0" bIns="0" anchor="t">
-            <a:spAutoFit/>
-          </a:bodyPr>
-          <a:lstStyle/>
-          <a:p>
-            <a:pPr algn="l">
-              <a:lnSpc>
-                <a:spcPct val="115000"/>
-              </a:lnSpc>
-            </a:pPr>
-            <a:r>
-              <a:rPr sz="1200" b="0">
-                <a:solidFill>
-                  <a:srgbClr val="0F172A"/>
-                </a:solidFill>
-                <a:latin typeface="Helvetica Neue"/>
-              </a:rPr>
-              <a:t>Variante multi-modèles MMALBP</a:t>
-            </a:r>
-          </a:p>
-        </p:txBody>
-      </p:sp>
-      <p:sp>
-        <p:nvSpPr>
-          <p:cNvPr id="18" name="Rectangle 17"/>
-          <p:cNvSpPr/>
-          <p:nvPr/>
-        </p:nvSpPr>
-        <p:spPr>
-          <a:xfrm>
-            <a:off x="457200" y="3675888"/>
-            <a:ext cx="109728" cy="109728"/>
-          </a:xfrm>
-          <a:prstGeom prst="rect">
-            <a:avLst/>
-          </a:prstGeom>
-          <a:solidFill>
-            <a:srgbClr val="1E3A8A"/>
-          </a:solidFill>
-          <a:ln>
-            <a:noFill/>
-          </a:ln>
-          <a:effectLst/>
-        </p:spPr>
-        <p:style>
-          <a:lnRef idx="1">
-            <a:schemeClr val="accent1"/>
-          </a:lnRef>
-          <a:fillRef idx="3">
-            <a:schemeClr val="accent1"/>
-          </a:fillRef>
-          <a:effectRef idx="2">
-            <a:schemeClr val="accent1"/>
-          </a:effectRef>
-          <a:fontRef idx="minor">
-            <a:schemeClr val="lt1"/>
-          </a:fontRef>
-        </p:style>
-        <p:txBody>
-          <a:bodyPr rtlCol="0" anchor="ctr"/>
-          <a:lstStyle/>
-          <a:p>
-            <a:pPr algn="ctr"/>
-          </a:p>
-        </p:txBody>
-      </p:sp>
-      <p:sp>
-        <p:nvSpPr>
-          <p:cNvPr id="19" name="TextBox 18"/>
-          <p:cNvSpPr txBox="1"/>
-          <p:nvPr/>
-        </p:nvSpPr>
-        <p:spPr>
-          <a:xfrm>
-            <a:off x="731520" y="3566160"/>
-            <a:ext cx="5029200" cy="365760"/>
-          </a:xfrm>
-          <a:prstGeom prst="rect">
-            <a:avLst/>
-          </a:prstGeom>
-          <a:noFill/>
-        </p:spPr>
-        <p:txBody>
-          <a:bodyPr wrap="square" lIns="0" rIns="0" tIns="0" bIns="0" anchor="t">
-            <a:spAutoFit/>
-          </a:bodyPr>
-          <a:lstStyle/>
-          <a:p>
-            <a:pPr algn="l">
-              <a:lnSpc>
-                <a:spcPct val="115000"/>
-              </a:lnSpc>
-            </a:pPr>
-            <a:r>
-              <a:rPr sz="1200" b="0">
-                <a:solidFill>
-                  <a:srgbClr val="0F172A"/>
-                </a:solidFill>
-                <a:latin typeface="Helvetica Neue"/>
-              </a:rPr>
-              <a:t>Bi-objectif : front de Pareto + somme pondérée</a:t>
-            </a:r>
-          </a:p>
-        </p:txBody>
-      </p:sp>
-      <p:sp>
-        <p:nvSpPr>
-          <p:cNvPr id="20" name="Rectangle 19"/>
-          <p:cNvSpPr/>
-          <p:nvPr/>
-        </p:nvSpPr>
-        <p:spPr>
-          <a:xfrm>
-            <a:off x="457200" y="4087368"/>
-            <a:ext cx="109728" cy="109728"/>
-          </a:xfrm>
-          <a:prstGeom prst="rect">
-            <a:avLst/>
-          </a:prstGeom>
-          <a:solidFill>
-            <a:srgbClr val="1E3A8A"/>
-          </a:solidFill>
-          <a:ln>
-            <a:noFill/>
-          </a:ln>
-          <a:effectLst/>
-        </p:spPr>
-        <p:style>
-          <a:lnRef idx="1">
-            <a:schemeClr val="accent1"/>
-          </a:lnRef>
-          <a:fillRef idx="3">
-            <a:schemeClr val="accent1"/>
-          </a:fillRef>
-          <a:effectRef idx="2">
-            <a:schemeClr val="accent1"/>
-          </a:effectRef>
-          <a:fontRef idx="minor">
-            <a:schemeClr val="lt1"/>
-          </a:fontRef>
-        </p:style>
-        <p:txBody>
-          <a:bodyPr rtlCol="0" anchor="ctr"/>
-          <a:lstStyle/>
-          <a:p>
-            <a:pPr algn="ctr"/>
-          </a:p>
-        </p:txBody>
-      </p:sp>
-      <p:sp>
-        <p:nvSpPr>
-          <p:cNvPr id="21" name="TextBox 20"/>
-          <p:cNvSpPr txBox="1"/>
-          <p:nvPr/>
-        </p:nvSpPr>
-        <p:spPr>
-          <a:xfrm>
-            <a:off x="731520" y="3977640"/>
-            <a:ext cx="5029200" cy="365760"/>
-          </a:xfrm>
-          <a:prstGeom prst="rect">
-            <a:avLst/>
-          </a:prstGeom>
-          <a:noFill/>
-        </p:spPr>
-        <p:txBody>
-          <a:bodyPr wrap="square" lIns="0" rIns="0" tIns="0" bIns="0" anchor="t">
-            <a:spAutoFit/>
-          </a:bodyPr>
-          <a:lstStyle/>
-          <a:p>
-            <a:pPr algn="l">
-              <a:lnSpc>
-                <a:spcPct val="115000"/>
-              </a:lnSpc>
-            </a:pPr>
-            <a:r>
-              <a:rPr sz="1200" b="0">
-                <a:solidFill>
-                  <a:srgbClr val="0F172A"/>
-                </a:solidFill>
-                <a:latin typeface="Helvetica Neue"/>
-              </a:rPr>
-              <a:t>Benchmark sur 25 instances Scholl 1993</a:t>
-            </a:r>
-          </a:p>
-        </p:txBody>
-      </p:sp>
-      <p:sp>
-        <p:nvSpPr>
-          <p:cNvPr id="22" name="Rectangle 21"/>
-          <p:cNvSpPr/>
-          <p:nvPr/>
-        </p:nvSpPr>
-        <p:spPr>
-          <a:xfrm>
-            <a:off x="457200" y="4498848"/>
-            <a:ext cx="109728" cy="109728"/>
-          </a:xfrm>
-          <a:prstGeom prst="rect">
-            <a:avLst/>
-          </a:prstGeom>
-          <a:solidFill>
-            <a:srgbClr val="1E3A8A"/>
-          </a:solidFill>
-          <a:ln>
-            <a:noFill/>
-          </a:ln>
-          <a:effectLst/>
-        </p:spPr>
-        <p:style>
-          <a:lnRef idx="1">
-            <a:schemeClr val="accent1"/>
-          </a:lnRef>
-          <a:fillRef idx="3">
-            <a:schemeClr val="accent1"/>
-          </a:fillRef>
-          <a:effectRef idx="2">
-            <a:schemeClr val="accent1"/>
-          </a:effectRef>
-          <a:fontRef idx="minor">
-            <a:schemeClr val="lt1"/>
-          </a:fontRef>
-        </p:style>
-        <p:txBody>
-          <a:bodyPr rtlCol="0" anchor="ctr"/>
-          <a:lstStyle/>
-          <a:p>
-            <a:pPr algn="ctr"/>
-          </a:p>
-        </p:txBody>
-      </p:sp>
-      <p:sp>
-        <p:nvSpPr>
-          <p:cNvPr id="23" name="TextBox 22"/>
-          <p:cNvSpPr txBox="1"/>
-          <p:nvPr/>
-        </p:nvSpPr>
-        <p:spPr>
-          <a:xfrm>
-            <a:off x="731520" y="4389120"/>
-            <a:ext cx="5029200" cy="365760"/>
-          </a:xfrm>
-          <a:prstGeom prst="rect">
-            <a:avLst/>
-          </a:prstGeom>
-          <a:noFill/>
-        </p:spPr>
-        <p:txBody>
-          <a:bodyPr wrap="square" lIns="0" rIns="0" tIns="0" bIns="0" anchor="t">
-            <a:spAutoFit/>
-          </a:bodyPr>
-          <a:lstStyle/>
-          <a:p>
-            <a:pPr algn="l">
-              <a:lnSpc>
-                <a:spcPct val="115000"/>
-              </a:lnSpc>
-            </a:pPr>
-            <a:r>
-              <a:rPr sz="1200" b="0">
-                <a:solidFill>
-                  <a:srgbClr val="0F172A"/>
-                </a:solidFill>
-                <a:latin typeface="Helvetica Neue"/>
-              </a:rPr>
-              <a:t>Application Streamlit interactive (5 modes)</a:t>
-            </a:r>
-          </a:p>
-        </p:txBody>
-      </p:sp>
-      <p:sp>
-        <p:nvSpPr>
-          <p:cNvPr id="24" name="Rectangle 23"/>
-          <p:cNvSpPr/>
-          <p:nvPr/>
-        </p:nvSpPr>
-        <p:spPr>
-          <a:xfrm>
-            <a:off x="457200" y="4910328"/>
-            <a:ext cx="109728" cy="109728"/>
-          </a:xfrm>
-          <a:prstGeom prst="rect">
-            <a:avLst/>
-          </a:prstGeom>
-          <a:solidFill>
-            <a:srgbClr val="1E3A8A"/>
-          </a:solidFill>
-          <a:ln>
-            <a:noFill/>
-          </a:ln>
-          <a:effectLst/>
-        </p:spPr>
-        <p:style>
-          <a:lnRef idx="1">
-            <a:schemeClr val="accent1"/>
-          </a:lnRef>
-          <a:fillRef idx="3">
-            <a:schemeClr val="accent1"/>
-          </a:fillRef>
-          <a:effectRef idx="2">
-            <a:schemeClr val="accent1"/>
-          </a:effectRef>
-          <a:fontRef idx="minor">
-            <a:schemeClr val="lt1"/>
-          </a:fontRef>
-        </p:style>
-        <p:txBody>
-          <a:bodyPr rtlCol="0" anchor="ctr"/>
-          <a:lstStyle/>
-          <a:p>
-            <a:pPr algn="ctr"/>
-          </a:p>
-        </p:txBody>
-      </p:sp>
-      <p:sp>
-        <p:nvSpPr>
-          <p:cNvPr id="25" name="TextBox 24"/>
-          <p:cNvSpPr txBox="1"/>
-          <p:nvPr/>
-        </p:nvSpPr>
-        <p:spPr>
-          <a:xfrm>
-            <a:off x="731520" y="4800600"/>
-            <a:ext cx="5029200" cy="365760"/>
-          </a:xfrm>
-          <a:prstGeom prst="rect">
-            <a:avLst/>
-          </a:prstGeom>
-          <a:noFill/>
-        </p:spPr>
-        <p:txBody>
-          <a:bodyPr wrap="square" lIns="0" rIns="0" tIns="0" bIns="0" anchor="t">
-            <a:spAutoFit/>
-          </a:bodyPr>
-          <a:lstStyle/>
-          <a:p>
-            <a:pPr algn="l">
-              <a:lnSpc>
-                <a:spcPct val="115000"/>
-              </a:lnSpc>
-            </a:pPr>
-            <a:r>
-              <a:rPr sz="1200" b="0">
-                <a:solidFill>
-                  <a:srgbClr val="0F172A"/>
-                </a:solidFill>
-                <a:latin typeface="Helvetica Neue"/>
-              </a:rPr>
-              <a:t>57 tests unitaires sur les modules critiques</a:t>
-            </a:r>
-          </a:p>
-        </p:txBody>
-      </p:sp>
-      <p:sp>
-        <p:nvSpPr>
-          <p:cNvPr id="26" name="TextBox 25"/>
-          <p:cNvSpPr txBox="1"/>
-          <p:nvPr/>
-        </p:nvSpPr>
-        <p:spPr>
-          <a:xfrm>
-            <a:off x="6400800" y="1554480"/>
-            <a:ext cx="5303520" cy="365760"/>
-          </a:xfrm>
-          <a:prstGeom prst="rect">
-            <a:avLst/>
-          </a:prstGeom>
-          <a:noFill/>
-        </p:spPr>
-        <p:txBody>
-          <a:bodyPr wrap="square" lIns="0" rIns="0" tIns="0" bIns="0" anchor="t">
-            <a:spAutoFit/>
-          </a:bodyPr>
-          <a:lstStyle/>
-          <a:p>
-            <a:pPr algn="l">
-              <a:lnSpc>
-                <a:spcPct val="115000"/>
-              </a:lnSpc>
-            </a:pPr>
-            <a:r>
-              <a:rPr sz="1000" b="1">
-                <a:solidFill>
-                  <a:srgbClr val="1E3A8A"/>
-                </a:solidFill>
-                <a:latin typeface="Helvetica Neue"/>
-              </a:rPr>
-              <a:t>PERSPECTIVES</a:t>
-            </a:r>
-          </a:p>
-        </p:txBody>
-      </p:sp>
-      <p:sp>
-        <p:nvSpPr>
-          <p:cNvPr id="27" name="Rectangle 26"/>
-          <p:cNvSpPr/>
-          <p:nvPr/>
-        </p:nvSpPr>
-        <p:spPr>
-          <a:xfrm>
-            <a:off x="6400800" y="1920240"/>
-            <a:ext cx="5303520" cy="685800"/>
-          </a:xfrm>
-          <a:prstGeom prst="rect">
-            <a:avLst/>
-          </a:prstGeom>
-          <a:solidFill>
-            <a:srgbClr val="F8FAFC"/>
-          </a:solidFill>
-          <a:ln w="12700">
-            <a:solidFill>
-              <a:srgbClr val="E2E8F0"/>
-            </a:solidFill>
-          </a:ln>
-          <a:effectLst/>
-        </p:spPr>
-        <p:style>
-          <a:lnRef idx="1">
-            <a:schemeClr val="accent1"/>
-          </a:lnRef>
-          <a:fillRef idx="3">
-            <a:schemeClr val="accent1"/>
-          </a:fillRef>
-          <a:effectRef idx="2">
-            <a:schemeClr val="accent1"/>
-          </a:effectRef>
-          <a:fontRef idx="minor">
-            <a:schemeClr val="lt1"/>
-          </a:fontRef>
-        </p:style>
-        <p:txBody>
-          <a:bodyPr rtlCol="0" anchor="ctr"/>
-          <a:lstStyle/>
-          <a:p>
-            <a:pPr algn="ctr"/>
-          </a:p>
-        </p:txBody>
-      </p:sp>
-      <p:sp>
-        <p:nvSpPr>
-          <p:cNvPr id="28" name="TextBox 27"/>
-          <p:cNvSpPr txBox="1"/>
-          <p:nvPr/>
-        </p:nvSpPr>
-        <p:spPr>
-          <a:xfrm>
-            <a:off x="6583680" y="2011680"/>
-            <a:ext cx="4937760" cy="365760"/>
-          </a:xfrm>
-          <a:prstGeom prst="rect">
-            <a:avLst/>
-          </a:prstGeom>
-          <a:noFill/>
-        </p:spPr>
-        <p:txBody>
-          <a:bodyPr wrap="square" lIns="0" rIns="0" tIns="0" bIns="0" anchor="t">
-            <a:spAutoFit/>
-          </a:bodyPr>
-          <a:lstStyle/>
-          <a:p>
-            <a:pPr algn="l">
-              <a:lnSpc>
-                <a:spcPct val="115000"/>
-              </a:lnSpc>
-            </a:pPr>
-            <a:r>
-              <a:rPr sz="1200" b="1">
-                <a:solidFill>
-                  <a:srgbClr val="0F172A"/>
-                </a:solidFill>
-                <a:latin typeface="Helvetica Neue"/>
-              </a:rPr>
-              <a:t>Instances de plus grande taille</a:t>
-            </a:r>
-          </a:p>
-        </p:txBody>
-      </p:sp>
-      <p:sp>
-        <p:nvSpPr>
-          <p:cNvPr id="29" name="TextBox 28"/>
-          <p:cNvSpPr txBox="1"/>
-          <p:nvPr/>
-        </p:nvSpPr>
-        <p:spPr>
-          <a:xfrm>
-            <a:off x="6583680" y="2286000"/>
-            <a:ext cx="4937760" cy="365760"/>
-          </a:xfrm>
-          <a:prstGeom prst="rect">
-            <a:avLst/>
-          </a:prstGeom>
-          <a:noFill/>
-        </p:spPr>
-        <p:txBody>
-          <a:bodyPr wrap="square" lIns="0" rIns="0" tIns="0" bIns="0" anchor="t">
-            <a:spAutoFit/>
-          </a:bodyPr>
-          <a:lstStyle/>
-          <a:p>
-            <a:pPr algn="l">
-              <a:lnSpc>
-                <a:spcPct val="115000"/>
-              </a:lnSpc>
-            </a:pPr>
-            <a:r>
-              <a:rPr sz="1000" b="0">
-                <a:solidFill>
-                  <a:srgbClr val="475569"/>
-                </a:solidFill>
-                <a:latin typeface="Helvetica Neue"/>
-              </a:rPr>
-              <a:t>Otto 2013 jusqu'à n = 1 000 tâches</a:t>
-            </a:r>
-          </a:p>
-        </p:txBody>
-      </p:sp>
-      <p:sp>
-        <p:nvSpPr>
-          <p:cNvPr id="30" name="Rectangle 29"/>
-          <p:cNvSpPr/>
-          <p:nvPr/>
-        </p:nvSpPr>
-        <p:spPr>
-          <a:xfrm>
-            <a:off x="6400800" y="2697480"/>
-            <a:ext cx="5303520" cy="685800"/>
-          </a:xfrm>
-          <a:prstGeom prst="rect">
-            <a:avLst/>
-          </a:prstGeom>
-          <a:solidFill>
-            <a:srgbClr val="F8FAFC"/>
-          </a:solidFill>
-          <a:ln w="12700">
-            <a:solidFill>
-              <a:srgbClr val="E2E8F0"/>
-            </a:solidFill>
-          </a:ln>
-          <a:effectLst/>
-        </p:spPr>
-        <p:style>
-          <a:lnRef idx="1">
-            <a:schemeClr val="accent1"/>
-          </a:lnRef>
-          <a:fillRef idx="3">
-            <a:schemeClr val="accent1"/>
-          </a:fillRef>
-          <a:effectRef idx="2">
-            <a:schemeClr val="accent1"/>
-          </a:effectRef>
-          <a:fontRef idx="minor">
-            <a:schemeClr val="lt1"/>
-          </a:fontRef>
-        </p:style>
-        <p:txBody>
-          <a:bodyPr rtlCol="0" anchor="ctr"/>
-          <a:lstStyle/>
-          <a:p>
-            <a:pPr algn="ctr"/>
-          </a:p>
-        </p:txBody>
-      </p:sp>
-      <p:sp>
-        <p:nvSpPr>
-          <p:cNvPr id="31" name="TextBox 30"/>
-          <p:cNvSpPr txBox="1"/>
-          <p:nvPr/>
-        </p:nvSpPr>
-        <p:spPr>
-          <a:xfrm>
-            <a:off x="6583680" y="2788920"/>
-            <a:ext cx="4937760" cy="365760"/>
-          </a:xfrm>
-          <a:prstGeom prst="rect">
-            <a:avLst/>
-          </a:prstGeom>
-          <a:noFill/>
-        </p:spPr>
-        <p:txBody>
-          <a:bodyPr wrap="square" lIns="0" rIns="0" tIns="0" bIns="0" anchor="t">
-            <a:spAutoFit/>
-          </a:bodyPr>
-          <a:lstStyle/>
-          <a:p>
-            <a:pPr algn="l">
-              <a:lnSpc>
-                <a:spcPct val="115000"/>
-              </a:lnSpc>
-            </a:pPr>
-            <a:r>
-              <a:rPr sz="1200" b="1">
-                <a:solidFill>
-                  <a:srgbClr val="0F172A"/>
-                </a:solidFill>
-                <a:latin typeface="Helvetica Neue"/>
-              </a:rPr>
-              <a:t>Warm-start hybride</a:t>
-            </a:r>
-          </a:p>
-        </p:txBody>
-      </p:sp>
-      <p:sp>
-        <p:nvSpPr>
-          <p:cNvPr id="32" name="TextBox 31"/>
-          <p:cNvSpPr txBox="1"/>
-          <p:nvPr/>
-        </p:nvSpPr>
-        <p:spPr>
-          <a:xfrm>
-            <a:off x="6583680" y="3063240"/>
-            <a:ext cx="4937760" cy="365760"/>
-          </a:xfrm>
-          <a:prstGeom prst="rect">
-            <a:avLst/>
-          </a:prstGeom>
-          <a:noFill/>
-        </p:spPr>
-        <p:txBody>
-          <a:bodyPr wrap="square" lIns="0" rIns="0" tIns="0" bIns="0" anchor="t">
-            <a:spAutoFit/>
-          </a:bodyPr>
-          <a:lstStyle/>
-          <a:p>
-            <a:pPr algn="l">
-              <a:lnSpc>
-                <a:spcPct val="115000"/>
-              </a:lnSpc>
-            </a:pPr>
-            <a:r>
-              <a:rPr sz="1000" b="0">
-                <a:solidFill>
-                  <a:srgbClr val="475569"/>
-                </a:solidFill>
-                <a:latin typeface="Helvetica Neue"/>
-              </a:rPr>
-              <a:t>RPW comme solution initiale pour CP-SAT</a:t>
-            </a:r>
-          </a:p>
-        </p:txBody>
-      </p:sp>
-      <p:sp>
-        <p:nvSpPr>
-          <p:cNvPr id="33" name="Rectangle 32"/>
-          <p:cNvSpPr/>
-          <p:nvPr/>
-        </p:nvSpPr>
-        <p:spPr>
-          <a:xfrm>
-            <a:off x="6400800" y="3474720"/>
-            <a:ext cx="5303520" cy="685800"/>
-          </a:xfrm>
-          <a:prstGeom prst="rect">
-            <a:avLst/>
-          </a:prstGeom>
-          <a:solidFill>
-            <a:srgbClr val="F8FAFC"/>
-          </a:solidFill>
-          <a:ln w="12700">
-            <a:solidFill>
-              <a:srgbClr val="E2E8F0"/>
-            </a:solidFill>
-          </a:ln>
-          <a:effectLst/>
-        </p:spPr>
-        <p:style>
-          <a:lnRef idx="1">
-            <a:schemeClr val="accent1"/>
-          </a:lnRef>
-          <a:fillRef idx="3">
-            <a:schemeClr val="accent1"/>
-          </a:fillRef>
-          <a:effectRef idx="2">
-            <a:schemeClr val="accent1"/>
-          </a:effectRef>
-          <a:fontRef idx="minor">
-            <a:schemeClr val="lt1"/>
-          </a:fontRef>
-        </p:style>
-        <p:txBody>
-          <a:bodyPr rtlCol="0" anchor="ctr"/>
-          <a:lstStyle/>
-          <a:p>
-            <a:pPr algn="ctr"/>
-          </a:p>
-        </p:txBody>
-      </p:sp>
-      <p:sp>
-        <p:nvSpPr>
-          <p:cNvPr id="34" name="TextBox 33"/>
-          <p:cNvSpPr txBox="1"/>
-          <p:nvPr/>
-        </p:nvSpPr>
-        <p:spPr>
-          <a:xfrm>
-            <a:off x="6583680" y="3566160"/>
-            <a:ext cx="4937760" cy="365760"/>
-          </a:xfrm>
-          <a:prstGeom prst="rect">
-            <a:avLst/>
-          </a:prstGeom>
-          <a:noFill/>
-        </p:spPr>
-        <p:txBody>
-          <a:bodyPr wrap="square" lIns="0" rIns="0" tIns="0" bIns="0" anchor="t">
-            <a:spAutoFit/>
-          </a:bodyPr>
-          <a:lstStyle/>
-          <a:p>
-            <a:pPr algn="l">
-              <a:lnSpc>
-                <a:spcPct val="115000"/>
-              </a:lnSpc>
-            </a:pPr>
-            <a:r>
-              <a:rPr sz="1200" b="1">
-                <a:solidFill>
-                  <a:srgbClr val="0F172A"/>
-                </a:solidFill>
-                <a:latin typeface="Helvetica Neue"/>
-              </a:rPr>
-              <a:t>Durées incertaines</a:t>
-            </a:r>
-          </a:p>
-        </p:txBody>
-      </p:sp>
-      <p:sp>
-        <p:nvSpPr>
-          <p:cNvPr id="35" name="TextBox 34"/>
-          <p:cNvSpPr txBox="1"/>
-          <p:nvPr/>
-        </p:nvSpPr>
-        <p:spPr>
-          <a:xfrm>
-            <a:off x="6583680" y="3840480"/>
-            <a:ext cx="4937760" cy="365760"/>
-          </a:xfrm>
-          <a:prstGeom prst="rect">
-            <a:avLst/>
-          </a:prstGeom>
-          <a:noFill/>
-        </p:spPr>
-        <p:txBody>
-          <a:bodyPr wrap="square" lIns="0" rIns="0" tIns="0" bIns="0" anchor="t">
-            <a:spAutoFit/>
-          </a:bodyPr>
-          <a:lstStyle/>
-          <a:p>
-            <a:pPr algn="l">
-              <a:lnSpc>
-                <a:spcPct val="115000"/>
-              </a:lnSpc>
-            </a:pPr>
-            <a:r>
-              <a:rPr sz="1000" b="0">
-                <a:solidFill>
-                  <a:srgbClr val="475569"/>
-                </a:solidFill>
-                <a:latin typeface="Helvetica Neue"/>
-              </a:rPr>
-              <a:t>Optimisation robuste / stochastique</a:t>
-            </a:r>
-          </a:p>
-        </p:txBody>
-      </p:sp>
-      <p:sp>
-        <p:nvSpPr>
-          <p:cNvPr id="36" name="Rectangle 35"/>
-          <p:cNvSpPr/>
-          <p:nvPr/>
-        </p:nvSpPr>
-        <p:spPr>
-          <a:xfrm>
-            <a:off x="6400800" y="4251960"/>
-            <a:ext cx="5303520" cy="685800"/>
-          </a:xfrm>
-          <a:prstGeom prst="rect">
-            <a:avLst/>
-          </a:prstGeom>
-          <a:solidFill>
-            <a:srgbClr val="F8FAFC"/>
-          </a:solidFill>
-          <a:ln w="12700">
-            <a:solidFill>
-              <a:srgbClr val="E2E8F0"/>
-            </a:solidFill>
-          </a:ln>
-          <a:effectLst/>
-        </p:spPr>
-        <p:style>
-          <a:lnRef idx="1">
-            <a:schemeClr val="accent1"/>
-          </a:lnRef>
-          <a:fillRef idx="3">
-            <a:schemeClr val="accent1"/>
-          </a:fillRef>
-          <a:effectRef idx="2">
-            <a:schemeClr val="accent1"/>
-          </a:effectRef>
-          <a:fontRef idx="minor">
-            <a:schemeClr val="lt1"/>
-          </a:fontRef>
-        </p:style>
-        <p:txBody>
-          <a:bodyPr rtlCol="0" anchor="ctr"/>
-          <a:lstStyle/>
-          <a:p>
-            <a:pPr algn="ctr"/>
-          </a:p>
-        </p:txBody>
-      </p:sp>
-      <p:sp>
-        <p:nvSpPr>
-          <p:cNvPr id="37" name="TextBox 36"/>
-          <p:cNvSpPr txBox="1"/>
-          <p:nvPr/>
-        </p:nvSpPr>
-        <p:spPr>
-          <a:xfrm>
-            <a:off x="6583680" y="4343400"/>
-            <a:ext cx="4937760" cy="365760"/>
-          </a:xfrm>
-          <a:prstGeom prst="rect">
-            <a:avLst/>
-          </a:prstGeom>
-          <a:noFill/>
-        </p:spPr>
-        <p:txBody>
-          <a:bodyPr wrap="square" lIns="0" rIns="0" tIns="0" bIns="0" anchor="t">
-            <a:spAutoFit/>
-          </a:bodyPr>
-          <a:lstStyle/>
-          <a:p>
-            <a:pPr algn="l">
-              <a:lnSpc>
-                <a:spcPct val="115000"/>
-              </a:lnSpc>
-            </a:pPr>
-            <a:r>
-              <a:rPr sz="1200" b="1">
-                <a:solidFill>
-                  <a:srgbClr val="0F172A"/>
-                </a:solidFill>
-                <a:latin typeface="Helvetica Neue"/>
-              </a:rPr>
-              <a:t>Changements de série</a:t>
-            </a:r>
-          </a:p>
-        </p:txBody>
-      </p:sp>
-      <p:sp>
-        <p:nvSpPr>
-          <p:cNvPr id="38" name="TextBox 37"/>
-          <p:cNvSpPr txBox="1"/>
-          <p:nvPr/>
-        </p:nvSpPr>
-        <p:spPr>
-          <a:xfrm>
-            <a:off x="6583680" y="4617720"/>
-            <a:ext cx="4937760" cy="365760"/>
-          </a:xfrm>
-          <a:prstGeom prst="rect">
-            <a:avLst/>
-          </a:prstGeom>
-          <a:noFill/>
-        </p:spPr>
-        <p:txBody>
-          <a:bodyPr wrap="square" lIns="0" rIns="0" tIns="0" bIns="0" anchor="t">
-            <a:spAutoFit/>
-          </a:bodyPr>
-          <a:lstStyle/>
-          <a:p>
-            <a:pPr algn="l">
-              <a:lnSpc>
-                <a:spcPct val="115000"/>
-              </a:lnSpc>
-            </a:pPr>
-            <a:r>
-              <a:rPr sz="1000" b="0">
-                <a:solidFill>
-                  <a:srgbClr val="475569"/>
-                </a:solidFill>
-                <a:latin typeface="Helvetica Neue"/>
-              </a:rPr>
-              <a:t>Modélisation des temps de changement</a:t>
-            </a:r>
-          </a:p>
-        </p:txBody>
-      </p:sp>
-      <p:sp>
-        <p:nvSpPr>
-          <p:cNvPr id="39" name="Rectangle 38"/>
-          <p:cNvSpPr/>
-          <p:nvPr/>
-        </p:nvSpPr>
-        <p:spPr>
-          <a:xfrm>
-            <a:off x="6400800" y="5029200"/>
-            <a:ext cx="5303520" cy="685800"/>
-          </a:xfrm>
-          <a:prstGeom prst="rect">
-            <a:avLst/>
-          </a:prstGeom>
-          <a:solidFill>
-            <a:srgbClr val="F8FAFC"/>
-          </a:solidFill>
-          <a:ln w="12700">
-            <a:solidFill>
-              <a:srgbClr val="E2E8F0"/>
-            </a:solidFill>
-          </a:ln>
-          <a:effectLst/>
-        </p:spPr>
-        <p:style>
-          <a:lnRef idx="1">
-            <a:schemeClr val="accent1"/>
-          </a:lnRef>
-          <a:fillRef idx="3">
-            <a:schemeClr val="accent1"/>
-          </a:fillRef>
-          <a:effectRef idx="2">
-            <a:schemeClr val="accent1"/>
-          </a:effectRef>
-          <a:fontRef idx="minor">
-            <a:schemeClr val="lt1"/>
-          </a:fontRef>
-        </p:style>
-        <p:txBody>
-          <a:bodyPr rtlCol="0" anchor="ctr"/>
-          <a:lstStyle/>
-          <a:p>
-            <a:pPr algn="ctr"/>
-          </a:p>
-        </p:txBody>
-      </p:sp>
-      <p:sp>
-        <p:nvSpPr>
-          <p:cNvPr id="40" name="TextBox 39"/>
-          <p:cNvSpPr txBox="1"/>
-          <p:nvPr/>
-        </p:nvSpPr>
-        <p:spPr>
-          <a:xfrm>
-            <a:off x="6583680" y="5120640"/>
-            <a:ext cx="4937760" cy="365760"/>
-          </a:xfrm>
-          <a:prstGeom prst="rect">
-            <a:avLst/>
-          </a:prstGeom>
-          <a:noFill/>
-        </p:spPr>
-        <p:txBody>
-          <a:bodyPr wrap="square" lIns="0" rIns="0" tIns="0" bIns="0" anchor="t">
-            <a:spAutoFit/>
-          </a:bodyPr>
-          <a:lstStyle/>
-          <a:p>
-            <a:pPr algn="l">
-              <a:lnSpc>
-                <a:spcPct val="115000"/>
-              </a:lnSpc>
-            </a:pPr>
-            <a:r>
-              <a:rPr sz="1200" b="1">
-                <a:solidFill>
-                  <a:srgbClr val="0F172A"/>
-                </a:solidFill>
-                <a:latin typeface="Helvetica Neue"/>
-              </a:rPr>
-              <a:t>Apprentissage de paramètres</a:t>
-            </a:r>
-          </a:p>
-        </p:txBody>
-      </p:sp>
-      <p:sp>
-        <p:nvSpPr>
-          <p:cNvPr id="41" name="TextBox 40"/>
-          <p:cNvSpPr txBox="1"/>
-          <p:nvPr/>
-        </p:nvSpPr>
-        <p:spPr>
-          <a:xfrm>
-            <a:off x="6583680" y="5394960"/>
-            <a:ext cx="4937760" cy="365760"/>
-          </a:xfrm>
-          <a:prstGeom prst="rect">
-            <a:avLst/>
-          </a:prstGeom>
-          <a:noFill/>
-        </p:spPr>
-        <p:txBody>
-          <a:bodyPr wrap="square" lIns="0" rIns="0" tIns="0" bIns="0" anchor="t">
-            <a:spAutoFit/>
-          </a:bodyPr>
-          <a:lstStyle/>
-          <a:p>
-            <a:pPr algn="l">
-              <a:lnSpc>
-                <a:spcPct val="115000"/>
-              </a:lnSpc>
-            </a:pPr>
-            <a:r>
-              <a:rPr sz="1000" b="0">
-                <a:solidFill>
-                  <a:srgbClr val="475569"/>
-                </a:solidFill>
-                <a:latin typeface="Helvetica Neue"/>
-              </a:rPr>
-              <a:t>Tuning α / β à partir de l'historique</a:t>
-            </a:r>
           </a:p>
         </p:txBody>
       </p:sp>
@@ -19626,8 +18147,8 @@
         </p:nvSpPr>
         <p:spPr>
           <a:xfrm>
-            <a:off x="457200" y="2926080"/>
-            <a:ext cx="11430000" cy="457200"/>
+            <a:off x="457200" y="3108960"/>
+            <a:ext cx="11430000" cy="640080"/>
           </a:xfrm>
           <a:prstGeom prst="rect">
             <a:avLst/>
@@ -19646,7 +18167,7 @@
               </a:lnSpc>
             </a:pPr>
             <a:r>
-              <a:rPr sz="4400" b="1">
+              <a:rPr sz="5400" b="1">
                 <a:solidFill>
                   <a:srgbClr val="0F172A"/>
                 </a:solidFill>
@@ -19659,52 +18180,13 @@
       </p:sp>
       <p:sp>
         <p:nvSpPr>
-          <p:cNvPr id="5" name="TextBox 4"/>
-          <p:cNvSpPr txBox="1"/>
-          <p:nvPr/>
-        </p:nvSpPr>
-        <p:spPr>
-          <a:xfrm>
-            <a:off x="457200" y="3749039"/>
-            <a:ext cx="11430000" cy="365760"/>
-          </a:xfrm>
-          <a:prstGeom prst="rect">
-            <a:avLst/>
-          </a:prstGeom>
-          <a:noFill/>
-        </p:spPr>
-        <p:txBody>
-          <a:bodyPr wrap="square" lIns="0" rIns="0" tIns="0" bIns="0" anchor="t">
-            <a:spAutoFit/>
-          </a:bodyPr>
-          <a:lstStyle/>
-          <a:p>
-            <a:pPr algn="ctr">
-              <a:lnSpc>
-                <a:spcPct val="115000"/>
-              </a:lnSpc>
-            </a:pPr>
-            <a:r>
-              <a:rPr sz="2000" b="0">
-                <a:solidFill>
-                  <a:srgbClr val="1E3A8A"/>
-                </a:solidFill>
-                <a:latin typeface="Helvetica Neue"/>
-              </a:rPr>
-              <a:t>Application Streamlit — 5 modes interactifs</a:t>
-            </a:r>
-          </a:p>
-        </p:txBody>
-      </p:sp>
-      <p:sp>
-        <p:nvSpPr>
-          <p:cNvPr id="6" name="Rectangle 5"/>
+          <p:cNvPr id="5" name="Rectangle 4"/>
           <p:cNvSpPr/>
           <p:nvPr/>
         </p:nvSpPr>
         <p:spPr>
           <a:xfrm>
-            <a:off x="5486400" y="4434840"/>
+            <a:off x="5486400" y="4023360"/>
             <a:ext cx="1280160" cy="28575"/>
           </a:xfrm>
           <a:prstGeom prst="rect">

</xml_diff>